<commit_message>
L8: blocchi e rientro (dispensa e slide)
Co-Authored-By: Claude Opus 5.5 <noreply@anthropic.com>
Claude-Session: https://claude.ai/code/session_014CzWDFXvYNxqLeD99LSN3G
</commit_message>
<xml_diff>
--- a/lezioni/L08_funzioni_cicli/slide.pptx
+++ b/lezioni/L08_funzioni_cicli/slide.pptx
@@ -14,9 +14,10 @@
     <p:sldId id="262" r:id="rId8"/>
     <p:sldId id="263" r:id="rId9"/>
     <p:sldId id="264" r:id="rId10"/>
+    <p:sldId id="265" r:id="rId11"/>
   </p:sldIdLst>
   <p:notesMasterIdLst>
-    <p:notesMasterId r:id="rId11"/>
+    <p:notesMasterId r:id="rId12"/>
   </p:notesMasterIdLst>
   <p:sldSz cx="12192000" cy="6858000"/>
   <p:notesSz cx="6858000" cy="12192000"/>
@@ -115,29 +116,30 @@
   <p:extLst>
     <p:ext uri="{521415D9-36F7-43E2-AB2F-B90AF26B5E84}">
       <p14:sectionLst xmlns:p14="http://schemas.microsoft.com/office/powerpoint/2010/main">
-        <p14:section name="Apertura" id="{a8506473-cbb5-c290-723b-f4dea79a8777}">
+        <p14:section name="Apertura" id="{9531b474-0873-aa8d-b839-34d8f104ba35}">
           <p14:sldIdLst>
             <p14:sldId id="256"/>
             <p14:sldId id="257"/>
           </p14:sldIdLst>
         </p14:section>
-        <p14:section name="Spiegazione" id="{b85d0098-ee27-73ad-b928-1aa6f7dde464}">
+        <p14:section name="Spiegazione" id="{802fcee4-af88-3abb-e3c7-35d7e6674826}">
           <p14:sldIdLst>
             <p14:sldId id="258"/>
             <p14:sldId id="259"/>
             <p14:sldId id="260"/>
             <p14:sldId id="261"/>
             <p14:sldId id="262"/>
-          </p14:sldIdLst>
-        </p14:section>
-        <p14:section name="Task" id="{bb91ace8-ce52-76be-d3f1-46f0a1626cb3}">
-          <p14:sldIdLst>
             <p14:sldId id="263"/>
           </p14:sldIdLst>
         </p14:section>
-        <p14:section name="Chiusura" id="{985fdca9-f0ce-1645-2dd8-3edbb78467ce}">
+        <p14:section name="Task" id="{5d372172-d81a-1546-6934-dca2fa5b2a0c}">
           <p14:sldIdLst>
             <p14:sldId id="264"/>
+          </p14:sldIdLst>
+        </p14:section>
+        <p14:section name="Chiusura" id="{3880d479-1f11-9e92-2f33-733329bc46cb}">
+          <p14:sldIdLst>
+            <p14:sldId id="265"/>
           </p14:sldIdLst>
         </p14:section>
       </p14:sectionLst>
@@ -586,6 +588,94 @@
 </p:notes>
 </file>
 
+<file path=ppt/notesSlides/notesSlide10.xml><?xml version="1.0" encoding="utf-8"?>
+<p:notes xmlns:a="http://schemas.openxmlformats.org/drawingml/2006/main" xmlns:r="http://schemas.openxmlformats.org/officeDocument/2006/relationships" xmlns:p="http://schemas.openxmlformats.org/presentationml/2006/main">
+  <p:cSld>
+    <p:spTree>
+      <p:nvGrpSpPr>
+        <p:cNvPr id="1" name=""/>
+        <p:cNvGrpSpPr/>
+        <p:nvPr/>
+      </p:nvGrpSpPr>
+      <p:grpSpPr>
+        <a:xfrm>
+          <a:off x="0" y="0"/>
+          <a:ext cx="0" cy="0"/>
+          <a:chOff x="0" y="0"/>
+          <a:chExt cx="0" cy="0"/>
+        </a:xfrm>
+      </p:grpSpPr>
+      <p:sp>
+        <p:nvSpPr>
+          <p:cNvPr id="2" name="Slide Image Placeholder 1"/>
+          <p:cNvSpPr>
+            <a:spLocks noGrp="1" noRot="1" noChangeAspect="1"/>
+          </p:cNvSpPr>
+          <p:nvPr>
+            <p:ph type="sldImg"/>
+          </p:nvPr>
+        </p:nvSpPr>
+        <p:spPr/>
+      </p:sp>
+      <p:sp>
+        <p:nvSpPr>
+          <p:cNvPr id="3" name="Notes Placeholder 2"/>
+          <p:cNvSpPr>
+            <a:spLocks noGrp="1"/>
+          </p:cNvSpPr>
+          <p:nvPr>
+            <p:ph type="body" idx="1"/>
+          </p:nvPr>
+        </p:nvSpPr>
+        <p:spPr/>
+        <p:txBody>
+          <a:bodyPr/>
+          <a:lstStyle/>
+          <a:p>
+            <a:r>
+              <a:rPr lang="en-US" dirty="0"/>
+              <a:t/>
+            </a:r>
+            <a:endParaRPr lang="en-US" dirty="0"/>
+          </a:p>
+        </p:txBody>
+      </p:sp>
+      <p:sp>
+        <p:nvSpPr>
+          <p:cNvPr id="4" name="Slide Number Placeholder 3"/>
+          <p:cNvSpPr>
+            <a:spLocks noGrp="1"/>
+          </p:cNvSpPr>
+          <p:nvPr>
+            <p:ph type="sldNum" sz="quarter" idx="10"/>
+          </p:nvPr>
+        </p:nvSpPr>
+        <p:spPr/>
+        <p:txBody>
+          <a:bodyPr/>
+          <a:lstStyle/>
+          <a:p>
+            <a:fld id="{F7021451-1387-4CA6-816F-3879F97B5CBC}" type="slidenum">
+              <a:rPr lang="en-US"/>
+              <a:t>10</a:t>
+            </a:fld>
+            <a:endParaRPr lang="en-US"/>
+          </a:p>
+        </p:txBody>
+      </p:sp>
+    </p:spTree>
+    <p:extLst>
+      <p:ext uri="{BB962C8B-B14F-4D97-AF65-F5344CB8AC3E}">
+        <p14:creationId xmlns:p14="http://schemas.microsoft.com/office/powerpoint/2010/main" val="1024086991"/>
+      </p:ext>
+    </p:extLst>
+  </p:cSld>
+  <p:clrMapOvr>
+    <a:masterClrMapping/>
+  </p:clrMapOvr>
+</p:notes>
+</file>
+
 <file path=ppt/notesSlides/notesSlide2.xml><?xml version="1.0" encoding="utf-8"?>
 <p:notes xmlns:a="http://schemas.openxmlformats.org/drawingml/2006/main" xmlns:r="http://schemas.openxmlformats.org/officeDocument/2006/relationships" xmlns:p="http://schemas.openxmlformats.org/presentationml/2006/main">
   <p:cSld>
@@ -984,7 +1074,7 @@
           <a:p>
             <a:r>
               <a:rPr lang="en-US" dirty="0"/>
-              <a:t>Mostrare il pannello dei file di Colab dopo il git clone. Path è il modo moderno di gestire i percorsi in Python.</a:t>
+              <a:t>DEMO: togliere il rientro a print(f.stem, ...) e far vedere l'IndentationError; poi spostare print("fatto") dentro il ciclo e far notare che viene stampato a ogni giro. Funzioni, cicli e if seguono tutti la stessa regola.</a:t>
             </a:r>
             <a:endParaRPr lang="en-US" dirty="0"/>
           </a:p>
@@ -1072,7 +1162,7 @@
           <a:p>
             <a:r>
               <a:rPr lang="en-US" dirty="0"/>
-              <a:t>Non anticipare quale file darà problemi.</a:t>
+              <a:t>Mostrare il pannello dei file di Colab dopo il git clone. Path è il modo moderno di gestire i percorsi in Python.</a:t>
             </a:r>
             <a:endParaRPr lang="en-US" dirty="0"/>
           </a:p>
@@ -1160,7 +1250,7 @@
           <a:p>
             <a:r>
               <a:rPr lang="en-US" dirty="0"/>
-              <a:t>Al passo 6 il ciclo si ferma: è voluto. Aiutare a leggere l'errore, non a risolverlo.</a:t>
+              <a:t>Non anticipare quale file darà problemi.</a:t>
             </a:r>
             <a:endParaRPr lang="en-US" dirty="0"/>
           </a:p>
@@ -1248,7 +1338,7 @@
           <a:p>
             <a:r>
               <a:rPr lang="en-US" dirty="0"/>
-              <a:t/>
+              <a:t>Al passo 6 il ciclo si ferma: è voluto. Aiutare a leggere l'errore, non a risolverlo.</a:t>
             </a:r>
             <a:endParaRPr lang="en-US" dirty="0"/>
           </a:p>
@@ -2118,6 +2208,107 @@
 </p:sld>
 </file>
 
+<file path=ppt/slides/slide10.xml><?xml version="1.0" encoding="utf-8"?>
+<p:sld xmlns:a="http://schemas.openxmlformats.org/drawingml/2006/main" xmlns:r="http://schemas.openxmlformats.org/officeDocument/2006/relationships" xmlns:p="http://schemas.openxmlformats.org/presentationml/2006/main">
+  <p:cSld name="Slide 10">
+    <p:spTree>
+      <p:nvGrpSpPr>
+        <p:cNvPr id="1" name=""/>
+        <p:cNvGrpSpPr/>
+        <p:nvPr/>
+      </p:nvGrpSpPr>
+      <p:grpSpPr>
+        <a:xfrm>
+          <a:off x="0" y="0"/>
+          <a:ext cx="0" cy="0"/>
+          <a:chOff x="0" y="0"/>
+          <a:chExt cx="0" cy="0"/>
+        </a:xfrm>
+      </p:grpSpPr>
+      <p:sp>
+        <p:nvSpPr>
+          <p:cNvPr id="2" name="Text 0"/>
+          <p:cNvSpPr/>
+          <p:nvPr>
+            <p:ph idx="100" type="title" hasCustomPrompt="1"/>
+          </p:nvPr>
+        </p:nvSpPr>
+        <p:spPr>
+          <a:xfrm>
+            <a:off x="731520" y="2103120"/>
+            <a:ext cx="10698480" cy="1463040"/>
+          </a:xfrm>
+          <a:prstGeom prst="rect">
+            <a:avLst/>
+          </a:prstGeom>
+          <a:noFill/>
+          <a:ln/>
+        </p:spPr>
+        <p:txBody>
+          <a:bodyPr wrap="square" lIns="0" tIns="0" rIns="0" bIns="0" rtlCol="0" anchor="b"/>
+          <a:lstStyle/>
+          <a:p>
+            <a:pPr algn="l" indent="0" marL="0">
+              <a:buNone/>
+            </a:pPr>
+            <a:r>
+              <a:rPr lang="en-US" sz="4800" b="1" dirty="0">
+                <a:solidFill>
+                  <a:srgbClr val="FFFFFF"/>
+                </a:solidFill>
+              </a:rPr>
+              <a:t>Prossima volta: dati da internet e una regressione</a:t>
+            </a:r>
+            <a:endParaRPr lang="en-US" sz="4800" dirty="0"/>
+          </a:p>
+        </p:txBody>
+      </p:sp>
+      <p:sp>
+        <p:nvSpPr>
+          <p:cNvPr id="3" name="Text 0"/>
+          <p:cNvSpPr/>
+          <p:nvPr>
+            <p:ph idx="101" type="body" hasCustomPrompt="1"/>
+          </p:nvPr>
+        </p:nvSpPr>
+        <p:spPr>
+          <a:xfrm>
+            <a:off x="731520" y="3749040"/>
+            <a:ext cx="10698480" cy="914400"/>
+          </a:xfrm>
+          <a:prstGeom prst="rect">
+            <a:avLst/>
+          </a:prstGeom>
+          <a:noFill/>
+          <a:ln/>
+        </p:spPr>
+        <p:txBody>
+          <a:bodyPr wrap="square" lIns="0" tIns="0" rIns="0" bIns="0" rtlCol="0" anchor="t"/>
+          <a:lstStyle/>
+          <a:p>
+            <a:pPr indent="0" marL="0">
+              <a:buNone/>
+            </a:pPr>
+            <a:r>
+              <a:rPr lang="en-US" sz="2200" dirty="0">
+                <a:solidFill>
+                  <a:srgbClr val="F4C06E"/>
+                </a:solidFill>
+              </a:rPr>
+              <a:t>Compito: Kaggle Learn – Python, funzioni e cicli (~40 min)</a:t>
+            </a:r>
+            <a:endParaRPr lang="en-US" sz="2200" dirty="0"/>
+          </a:p>
+        </p:txBody>
+      </p:sp>
+    </p:spTree>
+  </p:cSld>
+  <p:clrMapOvr>
+    <a:masterClrMapping/>
+  </p:clrMapOvr>
+</p:sld>
+</file>
+
 <file path=ppt/slides/slide2.xml><?xml version="1.0" encoding="utf-8"?>
 <p:sld xmlns:a="http://schemas.openxmlformats.org/drawingml/2006/main" xmlns:r="http://schemas.openxmlformats.org/officeDocument/2006/relationships" xmlns:p="http://schemas.openxmlformats.org/presentationml/2006/main">
   <p:cSld name="Slide 2">
@@ -4250,7 +4441,7 @@
                   <a:srgbClr val="0F4C5C"/>
                 </a:solidFill>
               </a:rPr>
-              <a:t>Funzione + ciclo + cartella</a:t>
+              <a:t>Blocchi e rientro</a:t>
             </a:r>
             <a:endParaRPr lang="en-US" sz="3600" dirty="0"/>
           </a:p>
@@ -4265,11 +4456,11 @@
         <p:spPr>
           <a:xfrm>
             <a:off x="548640" y="1737360"/>
-            <a:ext cx="7315200" cy="2926080"/>
+            <a:ext cx="6766560" cy="2743200"/>
           </a:xfrm>
           <a:prstGeom prst="roundRect">
             <a:avLst>
-              <a:gd name="adj" fmla="val 3750"/>
+              <a:gd name="adj" fmla="val 4000"/>
             </a:avLst>
           </a:prstGeom>
           <a:solidFill>
@@ -4323,7 +4514,7 @@
         <p:spPr>
           <a:xfrm>
             <a:off x="777240" y="2194560"/>
-            <a:ext cx="6858000" cy="2331720"/>
+            <a:ext cx="6309360" cy="2148840"/>
           </a:xfrm>
           <a:prstGeom prst="rect">
             <a:avLst/>
@@ -4339,7 +4530,7 @@
               <a:buNone/>
             </a:pPr>
             <a:r>
-              <a:rPr lang="en-US" sz="1600" dirty="0">
+              <a:rPr lang="en-US" sz="1700" dirty="0">
                 <a:solidFill>
                   <a:srgbClr val="FFFFFF"/>
                 </a:solidFill>
@@ -4347,22 +4538,16 @@
                 <a:ea typeface="Courier New" pitchFamily="34" charset="-122"/>
                 <a:cs typeface="Courier New" pitchFamily="34" charset="-120"/>
               </a:rPr>
-              <a:t>from pathlib import Path</a:t>
-            </a:r>
-            <a:endParaRPr lang="en-US" sz="1600" dirty="0"/>
-          </a:p>
-          <a:p>
-            <a:pPr indent="0" marL="0">
-              <a:buNone/>
-            </a:pPr>
-            <a:endParaRPr lang="en-US" sz="1600" dirty="0"/>
-          </a:p>
-          <a:p>
-            <a:pPr indent="0" marL="0">
-              <a:buNone/>
-            </a:pPr>
-            <a:r>
-              <a:rPr lang="en-US" sz="1600" dirty="0">
+              <a:t>for f in file:</a:t>
+            </a:r>
+            <a:endParaRPr lang="en-US" sz="1700" dirty="0"/>
+          </a:p>
+          <a:p>
+            <a:pPr indent="0" marL="0">
+              <a:buNone/>
+            </a:pPr>
+            <a:r>
+              <a:rPr lang="en-US" sz="1700" dirty="0">
                 <a:solidFill>
                   <a:srgbClr val="FFFFFF"/>
                 </a:solidFill>
@@ -4370,16 +4555,16 @@
                 <a:ea typeface="Courier New" pitchFamily="34" charset="-122"/>
                 <a:cs typeface="Courier New" pitchFamily="34" charset="-120"/>
               </a:rPr>
-              <a:t>file = sorted(Path("dati").glob("*.xlsx"))</a:t>
-            </a:r>
-            <a:endParaRPr lang="en-US" sz="1600" dirty="0"/>
-          </a:p>
-          <a:p>
-            <a:pPr indent="0" marL="0">
-              <a:buNone/>
-            </a:pPr>
-            <a:r>
-              <a:rPr lang="en-US" sz="1600" dirty="0">
+              <a:t>    d = pd.read_excel(f)</a:t>
+            </a:r>
+            <a:endParaRPr lang="en-US" sz="1700" dirty="0"/>
+          </a:p>
+          <a:p>
+            <a:pPr indent="0" marL="0">
+              <a:buNone/>
+            </a:pPr>
+            <a:r>
+              <a:rPr lang="en-US" sz="1700" dirty="0">
                 <a:solidFill>
                   <a:srgbClr val="FFFFFF"/>
                 </a:solidFill>
@@ -4387,16 +4572,16 @@
                 <a:ea typeface="Courier New" pitchFamily="34" charset="-122"/>
                 <a:cs typeface="Courier New" pitchFamily="34" charset="-120"/>
               </a:rPr>
-              <a:t>risultati = []</a:t>
-            </a:r>
-            <a:endParaRPr lang="en-US" sz="1600" dirty="0"/>
-          </a:p>
-          <a:p>
-            <a:pPr indent="0" marL="0">
-              <a:buNone/>
-            </a:pPr>
-            <a:r>
-              <a:rPr lang="en-US" sz="1600" dirty="0">
+              <a:t>    if len(d) &lt; 10:</a:t>
+            </a:r>
+            <a:endParaRPr lang="en-US" sz="1700" dirty="0"/>
+          </a:p>
+          <a:p>
+            <a:pPr indent="0" marL="0">
+              <a:buNone/>
+            </a:pPr>
+            <a:r>
+              <a:rPr lang="en-US" sz="1700" dirty="0">
                 <a:solidFill>
                   <a:srgbClr val="FFFFFF"/>
                 </a:solidFill>
@@ -4404,16 +4589,16 @@
                 <a:ea typeface="Courier New" pitchFamily="34" charset="-122"/>
                 <a:cs typeface="Courier New" pitchFamily="34" charset="-120"/>
               </a:rPr>
-              <a:t>for f in file:</a:t>
-            </a:r>
-            <a:endParaRPr lang="en-US" sz="1600" dirty="0"/>
-          </a:p>
-          <a:p>
-            <a:pPr indent="0" marL="0">
-              <a:buNone/>
-            </a:pPr>
-            <a:r>
-              <a:rPr lang="en-US" sz="1600" dirty="0">
+              <a:t>        print(f.stem, "poco affidabile")</a:t>
+            </a:r>
+            <a:endParaRPr lang="en-US" sz="1700" dirty="0"/>
+          </a:p>
+          <a:p>
+            <a:pPr indent="0" marL="0">
+              <a:buNone/>
+            </a:pPr>
+            <a:r>
+              <a:rPr lang="en-US" sz="1700" dirty="0">
                 <a:solidFill>
                   <a:srgbClr val="FFFFFF"/>
                 </a:solidFill>
@@ -4421,26 +4606,9 @@
                 <a:ea typeface="Courier New" pitchFamily="34" charset="-122"/>
                 <a:cs typeface="Courier New" pitchFamily="34" charset="-120"/>
               </a:rPr>
-              <a:t>    risultati.append(riepilogo(f))</a:t>
-            </a:r>
-            <a:endParaRPr lang="en-US" sz="1600" dirty="0"/>
-          </a:p>
-          <a:p>
-            <a:pPr indent="0" marL="0">
-              <a:buNone/>
-            </a:pPr>
-            <a:r>
-              <a:rPr lang="en-US" sz="1600" dirty="0">
-                <a:solidFill>
-                  <a:srgbClr val="FFFFFF"/>
-                </a:solidFill>
-                <a:latin typeface="Courier New" pitchFamily="34" charset="0"/>
-                <a:ea typeface="Courier New" pitchFamily="34" charset="-122"/>
-                <a:cs typeface="Courier New" pitchFamily="34" charset="-120"/>
-              </a:rPr>
-              <a:t>tab = pd.DataFrame(risultati)</a:t>
-            </a:r>
-            <a:endParaRPr lang="en-US" sz="1600" dirty="0"/>
+              <a:t>print("fatto")</a:t>
+            </a:r>
+            <a:endParaRPr lang="en-US" sz="1700" dirty="0"/>
           </a:p>
         </p:txBody>
       </p:sp>
@@ -4452,8 +4620,8 @@
         </p:nvSpPr>
         <p:spPr>
           <a:xfrm>
-            <a:off x="8229600" y="1828800"/>
-            <a:ext cx="3383280" cy="3840480"/>
+            <a:off x="7680960" y="1828800"/>
+            <a:ext cx="3931920" cy="4023360"/>
           </a:xfrm>
           <a:prstGeom prst="rect">
             <a:avLst/>
@@ -4478,7 +4646,7 @@
                   <a:srgbClr val="1F2A30"/>
                 </a:solidFill>
               </a:rPr>
-              <a:t>glob trova tutti i file che corrispondono a uno schema</a:t>
+              <a:t>I due punti aprono un blocco</a:t>
             </a:r>
             <a:endParaRPr lang="en-US" sz="1700" dirty="0"/>
           </a:p>
@@ -4496,7 +4664,7 @@
                   <a:srgbClr val="1F2A30"/>
                 </a:solidFill>
               </a:rPr>
-              <a:t>Ogni giro: un file, un riepilogo, aggiunto alla lista</a:t>
+              <a:t>Il rientro (4 spazi, tasto Tab) dice cosa ne fa parte</a:t>
             </a:r>
             <a:endParaRPr lang="en-US" sz="1700" dirty="0"/>
           </a:p>
@@ -4514,7 +4682,7 @@
                   <a:srgbClr val="1F2A30"/>
                 </a:solidFill>
               </a:rPr>
-              <a:t>Alla fine la lista diventa una tabella</a:t>
+              <a:t>Il blocco finisce quando si torna a sinistra</a:t>
             </a:r>
             <a:endParaRPr lang="en-US" sz="1700" dirty="0"/>
           </a:p>
@@ -4527,50 +4695,32 @@
               <a:buChar char="•"/>
             </a:pPr>
             <a:r>
+              <a:rPr lang="en-US" sz="1700" dirty="0">
+                <a:solidFill>
+                  <a:srgbClr val="1F2A30"/>
+                </a:solidFill>
+              </a:rPr>
+              <a:t>Dentro le parentesi il rientro non conta: è solo per leggere meglio</a:t>
+            </a:r>
+            <a:endParaRPr lang="en-US" sz="1700" dirty="0"/>
+          </a:p>
+          <a:p>
+            <a:pPr marL="342900" indent="-342900">
+              <a:spcAft>
+                <a:spcPts val="1000"/>
+              </a:spcAft>
+              <a:buSzPct val="100000"/>
+              <a:buChar char="•"/>
+            </a:pPr>
+            <a:r>
               <a:rPr lang="en-US" sz="1700" b="1" dirty="0">
                 <a:solidFill>
                   <a:srgbClr val="0F4C5C"/>
                 </a:solidFill>
               </a:rPr>
-              <a:t>20 file o 2.000: stesso codice</a:t>
+              <a:t>Rientro sbagliato? IndentationError</a:t>
             </a:r>
             <a:endParaRPr lang="en-US" sz="1700" dirty="0"/>
-          </a:p>
-        </p:txBody>
-      </p:sp>
-      <p:sp>
-        <p:nvSpPr>
-          <p:cNvPr id="7" name="Text 5"/>
-          <p:cNvSpPr txBox="1"/>
-          <p:nvPr/>
-        </p:nvSpPr>
-        <p:spPr>
-          <a:xfrm>
-            <a:off x="548640" y="5029200"/>
-            <a:ext cx="11064240" cy="457200"/>
-          </a:xfrm>
-          <a:prstGeom prst="rect">
-            <a:avLst/>
-          </a:prstGeom>
-          <a:noFill/>
-          <a:ln/>
-        </p:spPr>
-        <p:txBody>
-          <a:bodyPr wrap="square" lIns="0" tIns="0" rIns="0" bIns="0" rtlCol="0" anchor="ctr"/>
-          <a:lstStyle/>
-          <a:p>
-            <a:pPr indent="0" marL="0">
-              <a:buNone/>
-            </a:pPr>
-            <a:r>
-              <a:rPr lang="en-US" sz="1800" i="1" dirty="0">
-                <a:solidFill>
-                  <a:srgbClr val="0F4C5C"/>
-                </a:solidFill>
-              </a:rPr>
-              <a:t>In Colab i file del corso si scaricano con git clone: compaiono nel pannello a sinistra.</a:t>
-            </a:r>
-            <a:endParaRPr lang="en-US" sz="1800" dirty="0"/>
           </a:p>
         </p:txBody>
       </p:sp>
@@ -4676,7 +4826,7 @@
                   <a:srgbClr val="0F4C5C"/>
                 </a:solidFill>
               </a:rPr>
-              <a:t>Quando un ciclo si ferma</a:t>
+              <a:t>Funzione + ciclo + cartella</a:t>
             </a:r>
             <a:endParaRPr lang="en-US" sz="3600" dirty="0"/>
           </a:p>
@@ -4684,22 +4834,22 @@
       </p:sp>
       <p:sp>
         <p:nvSpPr>
-          <p:cNvPr id="3" name="Shape 1"/>
+          <p:cNvPr id="3" name="card-code"/>
           <p:cNvSpPr/>
           <p:nvPr/>
         </p:nvSpPr>
         <p:spPr>
           <a:xfrm>
             <a:off x="548640" y="1737360"/>
-            <a:ext cx="5394960" cy="2743200"/>
+            <a:ext cx="7315200" cy="2926080"/>
           </a:xfrm>
           <a:prstGeom prst="roundRect">
             <a:avLst>
-              <a:gd name="adj" fmla="val 4000"/>
+              <a:gd name="adj" fmla="val 3750"/>
             </a:avLst>
           </a:prstGeom>
           <a:solidFill>
-            <a:srgbClr val="EEF3F4"/>
+            <a:srgbClr val="1F2A30"/>
           </a:solidFill>
           <a:ln/>
         </p:spPr>
@@ -4712,8 +4862,8 @@
         </p:nvSpPr>
         <p:spPr>
           <a:xfrm>
-            <a:off x="822960" y="1965960"/>
-            <a:ext cx="4846320" cy="365760"/>
+            <a:off x="777240" y="1874520"/>
+            <a:ext cx="1828800" cy="274320"/>
           </a:xfrm>
           <a:prstGeom prst="rect">
             <a:avLst/>
@@ -4729,14 +4879,14 @@
               <a:buNone/>
             </a:pPr>
             <a:r>
-              <a:rPr lang="en-US" sz="1300" b="1" spc="200" kern="0" dirty="0">
-                <a:solidFill>
-                  <a:srgbClr val="8F5308"/>
-                </a:solidFill>
-              </a:rPr>
-              <a:t>IL TRUCCO</a:t>
-            </a:r>
-            <a:endParaRPr lang="en-US" sz="1300" dirty="0"/>
+              <a:rPr lang="en-US" sz="1100" b="1" spc="200" kern="0" dirty="0">
+                <a:solidFill>
+                  <a:srgbClr val="E09F3E"/>
+                </a:solidFill>
+              </a:rPr>
+              <a:t>PYTHON</a:t>
+            </a:r>
+            <a:endParaRPr lang="en-US" sz="1100" dirty="0"/>
           </a:p>
         </p:txBody>
       </p:sp>
@@ -4748,8 +4898,8 @@
         </p:nvSpPr>
         <p:spPr>
           <a:xfrm>
-            <a:off x="822960" y="2423160"/>
-            <a:ext cx="4846320" cy="1874520"/>
+            <a:off x="777240" y="2194560"/>
+            <a:ext cx="6858000" cy="2331720"/>
           </a:xfrm>
           <a:prstGeom prst="rect">
             <a:avLst/>
@@ -4765,38 +4915,204 @@
               <a:buNone/>
             </a:pPr>
             <a:r>
-              <a:rPr lang="en-US" sz="1900" dirty="0">
+              <a:rPr lang="en-US" sz="1600" dirty="0">
+                <a:solidFill>
+                  <a:srgbClr val="FFFFFF"/>
+                </a:solidFill>
+                <a:latin typeface="Courier New" pitchFamily="34" charset="0"/>
+                <a:ea typeface="Courier New" pitchFamily="34" charset="-122"/>
+                <a:cs typeface="Courier New" pitchFamily="34" charset="-120"/>
+              </a:rPr>
+              <a:t>from pathlib import Path</a:t>
+            </a:r>
+            <a:endParaRPr lang="en-US" sz="1600" dirty="0"/>
+          </a:p>
+          <a:p>
+            <a:pPr indent="0" marL="0">
+              <a:buNone/>
+            </a:pPr>
+            <a:endParaRPr lang="en-US" sz="1600" dirty="0"/>
+          </a:p>
+          <a:p>
+            <a:pPr indent="0" marL="0">
+              <a:buNone/>
+            </a:pPr>
+            <a:r>
+              <a:rPr lang="en-US" sz="1600" dirty="0">
+                <a:solidFill>
+                  <a:srgbClr val="FFFFFF"/>
+                </a:solidFill>
+                <a:latin typeface="Courier New" pitchFamily="34" charset="0"/>
+                <a:ea typeface="Courier New" pitchFamily="34" charset="-122"/>
+                <a:cs typeface="Courier New" pitchFamily="34" charset="-120"/>
+              </a:rPr>
+              <a:t>file = sorted(Path("dati").glob("*.xlsx"))</a:t>
+            </a:r>
+            <a:endParaRPr lang="en-US" sz="1600" dirty="0"/>
+          </a:p>
+          <a:p>
+            <a:pPr indent="0" marL="0">
+              <a:buNone/>
+            </a:pPr>
+            <a:r>
+              <a:rPr lang="en-US" sz="1600" dirty="0">
+                <a:solidFill>
+                  <a:srgbClr val="FFFFFF"/>
+                </a:solidFill>
+                <a:latin typeface="Courier New" pitchFamily="34" charset="0"/>
+                <a:ea typeface="Courier New" pitchFamily="34" charset="-122"/>
+                <a:cs typeface="Courier New" pitchFamily="34" charset="-120"/>
+              </a:rPr>
+              <a:t>risultati = []</a:t>
+            </a:r>
+            <a:endParaRPr lang="en-US" sz="1600" dirty="0"/>
+          </a:p>
+          <a:p>
+            <a:pPr indent="0" marL="0">
+              <a:buNone/>
+            </a:pPr>
+            <a:r>
+              <a:rPr lang="en-US" sz="1600" dirty="0">
+                <a:solidFill>
+                  <a:srgbClr val="FFFFFF"/>
+                </a:solidFill>
+                <a:latin typeface="Courier New" pitchFamily="34" charset="0"/>
+                <a:ea typeface="Courier New" pitchFamily="34" charset="-122"/>
+                <a:cs typeface="Courier New" pitchFamily="34" charset="-120"/>
+              </a:rPr>
+              <a:t>for f in file:</a:t>
+            </a:r>
+            <a:endParaRPr lang="en-US" sz="1600" dirty="0"/>
+          </a:p>
+          <a:p>
+            <a:pPr indent="0" marL="0">
+              <a:buNone/>
+            </a:pPr>
+            <a:r>
+              <a:rPr lang="en-US" sz="1600" dirty="0">
+                <a:solidFill>
+                  <a:srgbClr val="FFFFFF"/>
+                </a:solidFill>
+                <a:latin typeface="Courier New" pitchFamily="34" charset="0"/>
+                <a:ea typeface="Courier New" pitchFamily="34" charset="-122"/>
+                <a:cs typeface="Courier New" pitchFamily="34" charset="-120"/>
+              </a:rPr>
+              <a:t>    risultati.append(riepilogo(f))</a:t>
+            </a:r>
+            <a:endParaRPr lang="en-US" sz="1600" dirty="0"/>
+          </a:p>
+          <a:p>
+            <a:pPr indent="0" marL="0">
+              <a:buNone/>
+            </a:pPr>
+            <a:r>
+              <a:rPr lang="en-US" sz="1600" dirty="0">
+                <a:solidFill>
+                  <a:srgbClr val="FFFFFF"/>
+                </a:solidFill>
+                <a:latin typeface="Courier New" pitchFamily="34" charset="0"/>
+                <a:ea typeface="Courier New" pitchFamily="34" charset="-122"/>
+                <a:cs typeface="Courier New" pitchFamily="34" charset="-120"/>
+              </a:rPr>
+              <a:t>tab = pd.DataFrame(risultati)</a:t>
+            </a:r>
+            <a:endParaRPr lang="en-US" sz="1600" dirty="0"/>
+          </a:p>
+        </p:txBody>
+      </p:sp>
+      <p:sp>
+        <p:nvSpPr>
+          <p:cNvPr id="6" name="Text 4"/>
+          <p:cNvSpPr txBox="1"/>
+          <p:nvPr/>
+        </p:nvSpPr>
+        <p:spPr>
+          <a:xfrm>
+            <a:off x="8229600" y="1828800"/>
+            <a:ext cx="3383280" cy="3840480"/>
+          </a:xfrm>
+          <a:prstGeom prst="rect">
+            <a:avLst/>
+          </a:prstGeom>
+          <a:noFill/>
+          <a:ln/>
+        </p:spPr>
+        <p:txBody>
+          <a:bodyPr wrap="square" lIns="0" tIns="0" rIns="0" bIns="0" rtlCol="0" anchor="t"/>
+          <a:lstStyle/>
+          <a:p>
+            <a:pPr marL="342900" indent="-342900">
+              <a:spcAft>
+                <a:spcPts val="1000"/>
+              </a:spcAft>
+              <a:buSzPct val="100000"/>
+              <a:buChar char="•"/>
+            </a:pPr>
+            <a:r>
+              <a:rPr lang="en-US" sz="1700" dirty="0">
                 <a:solidFill>
                   <a:srgbClr val="1F2A30"/>
                 </a:solidFill>
               </a:rPr>
-              <a:t>Stampa il nome del file prima di elaborarlo. Se si ferma con un errore, l'ultimo nome stampato è il colpevole.</a:t>
-            </a:r>
-            <a:endParaRPr lang="en-US" sz="1900" dirty="0"/>
-          </a:p>
-        </p:txBody>
-      </p:sp>
-      <p:sp>
-        <p:nvSpPr>
-          <p:cNvPr id="6" name="Shape 4"/>
-          <p:cNvSpPr/>
-          <p:nvPr/>
-        </p:nvSpPr>
-        <p:spPr>
-          <a:xfrm>
-            <a:off x="6217920" y="1737360"/>
-            <a:ext cx="5394960" cy="2743200"/>
-          </a:xfrm>
-          <a:prstGeom prst="roundRect">
-            <a:avLst>
-              <a:gd name="adj" fmla="val 4000"/>
-            </a:avLst>
-          </a:prstGeom>
-          <a:solidFill>
-            <a:srgbClr val="0F4C5C"/>
-          </a:solidFill>
-          <a:ln/>
-        </p:spPr>
+              <a:t>glob trova tutti i file che corrispondono a uno schema</a:t>
+            </a:r>
+            <a:endParaRPr lang="en-US" sz="1700" dirty="0"/>
+          </a:p>
+          <a:p>
+            <a:pPr marL="342900" indent="-342900">
+              <a:spcAft>
+                <a:spcPts val="1000"/>
+              </a:spcAft>
+              <a:buSzPct val="100000"/>
+              <a:buChar char="•"/>
+            </a:pPr>
+            <a:r>
+              <a:rPr lang="en-US" sz="1700" dirty="0">
+                <a:solidFill>
+                  <a:srgbClr val="1F2A30"/>
+                </a:solidFill>
+              </a:rPr>
+              <a:t>Ogni giro: un file, un riepilogo, aggiunto alla lista</a:t>
+            </a:r>
+            <a:endParaRPr lang="en-US" sz="1700" dirty="0"/>
+          </a:p>
+          <a:p>
+            <a:pPr marL="342900" indent="-342900">
+              <a:spcAft>
+                <a:spcPts val="1000"/>
+              </a:spcAft>
+              <a:buSzPct val="100000"/>
+              <a:buChar char="•"/>
+            </a:pPr>
+            <a:r>
+              <a:rPr lang="en-US" sz="1700" dirty="0">
+                <a:solidFill>
+                  <a:srgbClr val="1F2A30"/>
+                </a:solidFill>
+              </a:rPr>
+              <a:t>Alla fine la lista diventa una tabella</a:t>
+            </a:r>
+            <a:endParaRPr lang="en-US" sz="1700" dirty="0"/>
+          </a:p>
+          <a:p>
+            <a:pPr marL="342900" indent="-342900">
+              <a:spcAft>
+                <a:spcPts val="1000"/>
+              </a:spcAft>
+              <a:buSzPct val="100000"/>
+              <a:buChar char="•"/>
+            </a:pPr>
+            <a:r>
+              <a:rPr lang="en-US" sz="1700" b="1" dirty="0">
+                <a:solidFill>
+                  <a:srgbClr val="0F4C5C"/>
+                </a:solidFill>
+              </a:rPr>
+              <a:t>20 file o 2.000: stesso codice</a:t>
+            </a:r>
+            <a:endParaRPr lang="en-US" sz="1700" dirty="0"/>
+          </a:p>
+        </p:txBody>
       </p:sp>
       <p:sp>
         <p:nvSpPr>
@@ -4806,8 +5122,8 @@
         </p:nvSpPr>
         <p:spPr>
           <a:xfrm>
-            <a:off x="6492240" y="1965960"/>
-            <a:ext cx="4846320" cy="365760"/>
+            <a:off x="548640" y="5029200"/>
+            <a:ext cx="11064240" cy="457200"/>
           </a:xfrm>
           <a:prstGeom prst="rect">
             <a:avLst/>
@@ -4823,84 +5139,12 @@
               <a:buNone/>
             </a:pPr>
             <a:r>
-              <a:rPr lang="en-US" sz="1300" b="1" spc="200" kern="0" dirty="0">
-                <a:solidFill>
-                  <a:srgbClr val="F4C06E"/>
-                </a:solidFill>
-              </a:rPr>
-              <a:t>POI</a:t>
-            </a:r>
-            <a:endParaRPr lang="en-US" sz="1300" dirty="0"/>
-          </a:p>
-        </p:txBody>
-      </p:sp>
-      <p:sp>
-        <p:nvSpPr>
-          <p:cNvPr id="8" name="Text 6"/>
-          <p:cNvSpPr txBox="1"/>
-          <p:nvPr/>
-        </p:nvSpPr>
-        <p:spPr>
-          <a:xfrm>
-            <a:off x="6492240" y="2423160"/>
-            <a:ext cx="4846320" cy="1874520"/>
-          </a:xfrm>
-          <a:prstGeom prst="rect">
-            <a:avLst/>
-          </a:prstGeom>
-          <a:noFill/>
-          <a:ln/>
-        </p:spPr>
-        <p:txBody>
-          <a:bodyPr wrap="square" lIns="0" tIns="0" rIns="0" bIns="0" rtlCol="0" anchor="t"/>
-          <a:lstStyle/>
-          <a:p>
-            <a:pPr indent="0" marL="0">
-              <a:buNone/>
-            </a:pPr>
-            <a:r>
-              <a:rPr lang="en-US" sz="1900" dirty="0">
-                <a:solidFill>
-                  <a:srgbClr val="FFFFFF"/>
-                </a:solidFill>
-              </a:rPr>
-              <a:t>Apri quel file e guardalo: cosa ha di diverso dagli altri? Correggi la funzione in modo che regga anche quel caso.</a:t>
-            </a:r>
-            <a:endParaRPr lang="en-US" sz="1900" dirty="0"/>
-          </a:p>
-        </p:txBody>
-      </p:sp>
-      <p:sp>
-        <p:nvSpPr>
-          <p:cNvPr id="9" name="Text 7"/>
-          <p:cNvSpPr txBox="1"/>
-          <p:nvPr/>
-        </p:nvSpPr>
-        <p:spPr>
-          <a:xfrm>
-            <a:off x="548640" y="4846320"/>
-            <a:ext cx="11064240" cy="457200"/>
-          </a:xfrm>
-          <a:prstGeom prst="rect">
-            <a:avLst/>
-          </a:prstGeom>
-          <a:noFill/>
-          <a:ln/>
-        </p:spPr>
-        <p:txBody>
-          <a:bodyPr wrap="square" lIns="0" tIns="0" rIns="0" bIns="0" rtlCol="0" anchor="ctr"/>
-          <a:lstStyle/>
-          <a:p>
-            <a:pPr indent="0" marL="0">
-              <a:buNone/>
-            </a:pPr>
-            <a:r>
               <a:rPr lang="en-US" sz="1800" i="1" dirty="0">
                 <a:solidFill>
                   <a:srgbClr val="0F4C5C"/>
                 </a:solidFill>
               </a:rPr>
-              <a:t>I file «tutti uguali» non sono mai tutti uguali.</a:t>
+              <a:t>In Colab i file del corso si scaricano con git clone: compaiono nel pannello a sinistra.</a:t>
             </a:r>
             <a:endParaRPr lang="en-US" sz="1800" dirty="0"/>
           </a:p>
@@ -4986,8 +5230,8 @@
         </p:nvSpPr>
         <p:spPr>
           <a:xfrm>
-            <a:off x="731520" y="2194560"/>
-            <a:ext cx="10698480" cy="1280160"/>
+            <a:off x="548640" y="365760"/>
+            <a:ext cx="11064240" cy="822960"/>
           </a:xfrm>
           <a:prstGeom prst="rect">
             <a:avLst/>
@@ -4996,36 +5240,222 @@
           <a:ln/>
         </p:spPr>
         <p:txBody>
-          <a:bodyPr wrap="square" lIns="0" tIns="0" rIns="0" bIns="0" rtlCol="0" anchor="b"/>
+          <a:bodyPr wrap="square" lIns="0" tIns="0" rIns="0" bIns="0" rtlCol="0" anchor="ctr"/>
           <a:lstStyle/>
           <a:p>
             <a:pPr algn="l" indent="0" marL="0">
               <a:buNone/>
             </a:pPr>
             <a:r>
-              <a:rPr lang="en-US" sz="5400" b="1" dirty="0">
+              <a:rPr lang="en-US" sz="3600" b="1" dirty="0">
+                <a:solidFill>
+                  <a:srgbClr val="0F4C5C"/>
+                </a:solidFill>
+              </a:rPr>
+              <a:t>Quando un ciclo si ferma</a:t>
+            </a:r>
+            <a:endParaRPr lang="en-US" sz="3600" dirty="0"/>
+          </a:p>
+        </p:txBody>
+      </p:sp>
+      <p:sp>
+        <p:nvSpPr>
+          <p:cNvPr id="3" name="Shape 1"/>
+          <p:cNvSpPr/>
+          <p:nvPr/>
+        </p:nvSpPr>
+        <p:spPr>
+          <a:xfrm>
+            <a:off x="548640" y="1737360"/>
+            <a:ext cx="5394960" cy="2743200"/>
+          </a:xfrm>
+          <a:prstGeom prst="roundRect">
+            <a:avLst>
+              <a:gd name="adj" fmla="val 4000"/>
+            </a:avLst>
+          </a:prstGeom>
+          <a:solidFill>
+            <a:srgbClr val="EEF3F4"/>
+          </a:solidFill>
+          <a:ln/>
+        </p:spPr>
+      </p:sp>
+      <p:sp>
+        <p:nvSpPr>
+          <p:cNvPr id="4" name="Text 2"/>
+          <p:cNvSpPr txBox="1"/>
+          <p:nvPr/>
+        </p:nvSpPr>
+        <p:spPr>
+          <a:xfrm>
+            <a:off x="822960" y="1965960"/>
+            <a:ext cx="4846320" cy="365760"/>
+          </a:xfrm>
+          <a:prstGeom prst="rect">
+            <a:avLst/>
+          </a:prstGeom>
+          <a:noFill/>
+          <a:ln/>
+        </p:spPr>
+        <p:txBody>
+          <a:bodyPr wrap="square" lIns="0" tIns="0" rIns="0" bIns="0" rtlCol="0" anchor="ctr"/>
+          <a:lstStyle/>
+          <a:p>
+            <a:pPr indent="0" marL="0">
+              <a:buNone/>
+            </a:pPr>
+            <a:r>
+              <a:rPr lang="en-US" sz="1300" b="1" spc="200" kern="0" dirty="0">
+                <a:solidFill>
+                  <a:srgbClr val="8F5308"/>
+                </a:solidFill>
+              </a:rPr>
+              <a:t>IL TRUCCO</a:t>
+            </a:r>
+            <a:endParaRPr lang="en-US" sz="1300" dirty="0"/>
+          </a:p>
+        </p:txBody>
+      </p:sp>
+      <p:sp>
+        <p:nvSpPr>
+          <p:cNvPr id="5" name="Text 3"/>
+          <p:cNvSpPr txBox="1"/>
+          <p:nvPr/>
+        </p:nvSpPr>
+        <p:spPr>
+          <a:xfrm>
+            <a:off x="822960" y="2423160"/>
+            <a:ext cx="4846320" cy="1874520"/>
+          </a:xfrm>
+          <a:prstGeom prst="rect">
+            <a:avLst/>
+          </a:prstGeom>
+          <a:noFill/>
+          <a:ln/>
+        </p:spPr>
+        <p:txBody>
+          <a:bodyPr wrap="square" lIns="0" tIns="0" rIns="0" bIns="0" rtlCol="0" anchor="t"/>
+          <a:lstStyle/>
+          <a:p>
+            <a:pPr indent="0" marL="0">
+              <a:buNone/>
+            </a:pPr>
+            <a:r>
+              <a:rPr lang="en-US" sz="1900" dirty="0">
+                <a:solidFill>
+                  <a:srgbClr val="1F2A30"/>
+                </a:solidFill>
+              </a:rPr>
+              <a:t>Stampa il nome del file prima di elaborarlo. Se si ferma con un errore, l'ultimo nome stampato è il colpevole.</a:t>
+            </a:r>
+            <a:endParaRPr lang="en-US" sz="1900" dirty="0"/>
+          </a:p>
+        </p:txBody>
+      </p:sp>
+      <p:sp>
+        <p:nvSpPr>
+          <p:cNvPr id="6" name="Shape 4"/>
+          <p:cNvSpPr/>
+          <p:nvPr/>
+        </p:nvSpPr>
+        <p:spPr>
+          <a:xfrm>
+            <a:off x="6217920" y="1737360"/>
+            <a:ext cx="5394960" cy="2743200"/>
+          </a:xfrm>
+          <a:prstGeom prst="roundRect">
+            <a:avLst>
+              <a:gd name="adj" fmla="val 4000"/>
+            </a:avLst>
+          </a:prstGeom>
+          <a:solidFill>
+            <a:srgbClr val="0F4C5C"/>
+          </a:solidFill>
+          <a:ln/>
+        </p:spPr>
+      </p:sp>
+      <p:sp>
+        <p:nvSpPr>
+          <p:cNvPr id="7" name="Text 5"/>
+          <p:cNvSpPr txBox="1"/>
+          <p:nvPr/>
+        </p:nvSpPr>
+        <p:spPr>
+          <a:xfrm>
+            <a:off x="6492240" y="1965960"/>
+            <a:ext cx="4846320" cy="365760"/>
+          </a:xfrm>
+          <a:prstGeom prst="rect">
+            <a:avLst/>
+          </a:prstGeom>
+          <a:noFill/>
+          <a:ln/>
+        </p:spPr>
+        <p:txBody>
+          <a:bodyPr wrap="square" lIns="0" tIns="0" rIns="0" bIns="0" rtlCol="0" anchor="ctr"/>
+          <a:lstStyle/>
+          <a:p>
+            <a:pPr indent="0" marL="0">
+              <a:buNone/>
+            </a:pPr>
+            <a:r>
+              <a:rPr lang="en-US" sz="1300" b="1" spc="200" kern="0" dirty="0">
+                <a:solidFill>
+                  <a:srgbClr val="F4C06E"/>
+                </a:solidFill>
+              </a:rPr>
+              <a:t>POI</a:t>
+            </a:r>
+            <a:endParaRPr lang="en-US" sz="1300" dirty="0"/>
+          </a:p>
+        </p:txBody>
+      </p:sp>
+      <p:sp>
+        <p:nvSpPr>
+          <p:cNvPr id="8" name="Text 6"/>
+          <p:cNvSpPr txBox="1"/>
+          <p:nvPr/>
+        </p:nvSpPr>
+        <p:spPr>
+          <a:xfrm>
+            <a:off x="6492240" y="2423160"/>
+            <a:ext cx="4846320" cy="1874520"/>
+          </a:xfrm>
+          <a:prstGeom prst="rect">
+            <a:avLst/>
+          </a:prstGeom>
+          <a:noFill/>
+          <a:ln/>
+        </p:spPr>
+        <p:txBody>
+          <a:bodyPr wrap="square" lIns="0" tIns="0" rIns="0" bIns="0" rtlCol="0" anchor="t"/>
+          <a:lstStyle/>
+          <a:p>
+            <a:pPr indent="0" marL="0">
+              <a:buNone/>
+            </a:pPr>
+            <a:r>
+              <a:rPr lang="en-US" sz="1900" dirty="0">
                 <a:solidFill>
                   <a:srgbClr val="FFFFFF"/>
                 </a:solidFill>
               </a:rPr>
-              <a:t>Task: 20 file, un riepilogo</a:t>
-            </a:r>
-            <a:endParaRPr lang="en-US" sz="5400" dirty="0"/>
-          </a:p>
-        </p:txBody>
-      </p:sp>
-      <p:sp>
-        <p:nvSpPr>
-          <p:cNvPr id="3" name="Text 0"/>
-          <p:cNvSpPr/>
-          <p:nvPr>
-            <p:ph idx="101" type="body" hasCustomPrompt="1"/>
-          </p:nvPr>
-        </p:nvSpPr>
-        <p:spPr>
-          <a:xfrm>
-            <a:off x="731520" y="3657600"/>
-            <a:ext cx="10698480" cy="1463040"/>
+              <a:t>Apri quel file e guardalo: cosa ha di diverso dagli altri? Correggi la funzione in modo che regga anche quel caso.</a:t>
+            </a:r>
+            <a:endParaRPr lang="en-US" sz="1900" dirty="0"/>
+          </a:p>
+        </p:txBody>
+      </p:sp>
+      <p:sp>
+        <p:nvSpPr>
+          <p:cNvPr id="9" name="Text 7"/>
+          <p:cNvSpPr txBox="1"/>
+          <p:nvPr/>
+        </p:nvSpPr>
+        <p:spPr>
+          <a:xfrm>
+            <a:off x="548640" y="4846320"/>
+            <a:ext cx="11064240" cy="457200"/>
           </a:xfrm>
           <a:prstGeom prst="rect">
             <a:avLst/>
@@ -5034,35 +5464,66 @@
           <a:ln/>
         </p:spPr>
         <p:txBody>
-          <a:bodyPr wrap="square" lIns="0" tIns="0" rIns="0" bIns="0" rtlCol="0" anchor="t"/>
-          <a:lstStyle/>
-          <a:p>
-            <a:pPr indent="0" marL="0">
-              <a:buNone/>
-            </a:pPr>
-            <a:r>
-              <a:rPr lang="en-US" sz="2200" dirty="0">
-                <a:solidFill>
-                  <a:srgbClr val="B8C4CB"/>
-                </a:solidFill>
-              </a:rPr>
-              <a:t>Scrivi la ricetta una volta, ripetila su tutti.</a:t>
-            </a:r>
-            <a:endParaRPr lang="en-US" sz="2200" dirty="0"/>
-          </a:p>
-          <a:p>
-            <a:pPr indent="0" marL="0">
-              <a:buNone/>
-            </a:pPr>
-            <a:r>
-              <a:rPr lang="en-US" sz="2200" dirty="0">
-                <a:solidFill>
-                  <a:srgbClr val="B8C4CB"/>
-                </a:solidFill>
-              </a:rPr>
-              <a:t>60 minuti · apri il notebook dal README</a:t>
-            </a:r>
-            <a:endParaRPr lang="en-US" sz="2200" dirty="0"/>
+          <a:bodyPr wrap="square" lIns="0" tIns="0" rIns="0" bIns="0" rtlCol="0" anchor="ctr"/>
+          <a:lstStyle/>
+          <a:p>
+            <a:pPr indent="0" marL="0">
+              <a:buNone/>
+            </a:pPr>
+            <a:r>
+              <a:rPr lang="en-US" sz="1800" i="1" dirty="0">
+                <a:solidFill>
+                  <a:srgbClr val="0F4C5C"/>
+                </a:solidFill>
+              </a:rPr>
+              <a:t>I file «tutti uguali» non sono mai tutti uguali.</a:t>
+            </a:r>
+            <a:endParaRPr lang="en-US" sz="1800" dirty="0"/>
+          </a:p>
+        </p:txBody>
+      </p:sp>
+      <p:sp>
+        <p:nvSpPr>
+          <p:cNvPr id="25" name="Slide Number Placeholder 0"/>
+          <p:cNvSpPr>
+            <a:spLocks noGrp="1"/>
+          </p:cNvSpPr>
+          <p:nvPr>
+            <p:ph type="sldNum" sz="quarter" idx="4294967295"/>
+          </p:nvPr>
+        </p:nvSpPr>
+        <p:spPr>
+          <a:xfrm>
+            <a:off x="11155680" y="6400800"/>
+            <a:ext cx="457200" cy="274320"/>
+          </a:xfrm>
+          <a:prstGeom prst="rect">
+            <a:avLst/>
+          </a:prstGeom>
+          <a:extLst>
+            <a:ext uri="{C572A759-6A51-4108-AA02-DFA0A04FC94B}">
+              <ma14:wrappingTextBoxFlag xmlns:ma14="http://schemas.microsoft.com/office/mac/drawingml/2011/main" val="0"/>
+            </a:ext>
+          </a:extLst>
+        </p:spPr>
+        <p:txBody>
+          <a:bodyPr/>
+          <a:lstStyle>
+            <a:lvl1pPr>
+              <a:defRPr sz="1000">
+                <a:solidFill>
+                  <a:srgbClr val="5C6F7B"/>
+                </a:solidFill>
+              </a:defRPr>
+            </a:lvl1pPr>
+          </a:lstStyle>
+          <a:p>
+            <a:pPr algn="r"/>
+            <a:fld id="{F7021451-1387-4CA6-816F-3879F97B5CBC}" type="slidenum">
+              <a:rPr b="0" lang="en-US"/>
+              <a:t>8</a:t>
+            </a:fld>
+            <a:endParaRPr lang="en-US"/>
           </a:p>
         </p:txBody>
       </p:sp>
@@ -5101,8 +5562,8 @@
         </p:nvSpPr>
         <p:spPr>
           <a:xfrm>
-            <a:off x="731520" y="2103120"/>
-            <a:ext cx="10698480" cy="1463040"/>
+            <a:off x="731520" y="2194560"/>
+            <a:ext cx="10698480" cy="1280160"/>
           </a:xfrm>
           <a:prstGeom prst="rect">
             <a:avLst/>
@@ -5118,14 +5579,14 @@
               <a:buNone/>
             </a:pPr>
             <a:r>
-              <a:rPr lang="en-US" sz="4800" b="1" dirty="0">
+              <a:rPr lang="en-US" sz="5400" b="1" dirty="0">
                 <a:solidFill>
                   <a:srgbClr val="FFFFFF"/>
                 </a:solidFill>
               </a:rPr>
-              <a:t>Prossima volta: dati da internet e una regressione</a:t>
-            </a:r>
-            <a:endParaRPr lang="en-US" sz="4800" dirty="0"/>
+              <a:t>Task: 20 file, un riepilogo</a:t>
+            </a:r>
+            <a:endParaRPr lang="en-US" sz="5400" dirty="0"/>
           </a:p>
         </p:txBody>
       </p:sp>
@@ -5139,8 +5600,8 @@
         </p:nvSpPr>
         <p:spPr>
           <a:xfrm>
-            <a:off x="731520" y="3749040"/>
-            <a:ext cx="10698480" cy="914400"/>
+            <a:off x="731520" y="3657600"/>
+            <a:ext cx="10698480" cy="1463040"/>
           </a:xfrm>
           <a:prstGeom prst="rect">
             <a:avLst/>
@@ -5158,10 +5619,24 @@
             <a:r>
               <a:rPr lang="en-US" sz="2200" dirty="0">
                 <a:solidFill>
-                  <a:srgbClr val="F4C06E"/>
-                </a:solidFill>
-              </a:rPr>
-              <a:t>Compito: Kaggle Learn – Python, funzioni e cicli (~40 min)</a:t>
+                  <a:srgbClr val="B8C4CB"/>
+                </a:solidFill>
+              </a:rPr>
+              <a:t>Scrivi la ricetta una volta, ripetila su tutti.</a:t>
+            </a:r>
+            <a:endParaRPr lang="en-US" sz="2200" dirty="0"/>
+          </a:p>
+          <a:p>
+            <a:pPr indent="0" marL="0">
+              <a:buNone/>
+            </a:pPr>
+            <a:r>
+              <a:rPr lang="en-US" sz="2200" dirty="0">
+                <a:solidFill>
+                  <a:srgbClr val="B8C4CB"/>
+                </a:solidFill>
+              </a:rPr>
+              <a:t>60 minuti · apri il notebook dal README</a:t>
             </a:r>
             <a:endParaRPr lang="en-US" sz="2200" dirty="0"/>
           </a:p>

</xml_diff>